<commit_message>
soutenance: pptx aligne sur le memoire actuel + Word regenere
PPTX (17 slides) :
- slide titre : encadreur M. FEZEU
- slide Resultats OS2 : evolution LORO (escalier -1,77 -> +0,29 -> +0,20), structure du R2
- slide Jumeau : honnetete Run #21 touche / Run #22 manque (scorecard) + 3 estimateurs
  + lecon interpole/extrapole (plus de sur-affirmation "≥2 fois")
- slide OS1 : etalonnage par substitution (validation 4,7 Ohm)

Coherence facteur HX711 : retrait du "×0,32" en §III.1.1 + slide (contredisait
l'annexe + Figure II.2 qui affichent ×33,7). §III.1.1 rendu neutre (methode +
validation 4,7 Ohm + renvoi Figure II.2). Nombre a trancher par Ricky.

Co-Authored-By: Claude Opus 4.8 <noreply@anthropic.com>
</commit_message>
<xml_diff>
--- a/soutenance/Soutenance_Corrosion_BATOUMBI.pptx
+++ b/soutenance/Soutenance_Corrosion_BATOUMBI.pptx
@@ -3540,7 +3540,25 @@
                 </a:solidFill>
                 <a:latin typeface="Calibri"/>
               </a:rPr>
-              <a:t>Sous la supervision de   </a:t>
+              <a:t>Sous l'encadrement de   </a:t>
+            </a:r>
+            <a:r>
+              <a:rPr sz="1500" b="1" i="0">
+                <a:solidFill>
+                  <a:srgbClr val="FFFFFF"/>
+                </a:solidFill>
+                <a:latin typeface="Calibri"/>
+              </a:rPr>
+              <a:t>M. FEZEU</a:t>
+            </a:r>
+            <a:r>
+              <a:rPr sz="1300" b="0" i="0">
+                <a:solidFill>
+                  <a:srgbClr val="6B7A82"/>
+                </a:solidFill>
+                <a:latin typeface="Calibri"/>
+              </a:rPr>
+              <a:t>      ·      Supervision   </a:t>
             </a:r>
             <a:r>
               <a:rPr sz="1500" b="1" i="0">
@@ -5893,14 +5911,14 @@
                 </a:solidFill>
                 <a:latin typeface="Georgia"/>
               </a:rPr>
-              <a:t>Jumeau numérique : prédire puis confirmer</a:t>
+              <a:t>Jumeau numérique : prédire, confirmer, apprendre des écarts</a:t>
             </a:r>
           </a:p>
         </p:txBody>
       </p:sp>
       <p:pic>
         <p:nvPicPr>
-          <p:cNvPr id="6" name="Picture 5" descr="fig_simulateur_run21_nonparam.png"/>
+          <p:cNvPr id="6" name="Picture 5" descr="fig_iii3_band_scorecard.png"/>
           <p:cNvPicPr>
             <a:picLocks noChangeAspect="1"/>
           </p:cNvPicPr>
@@ -5914,8 +5932,8 @@
         </p:blipFill>
         <p:spPr>
           <a:xfrm>
-            <a:off x="6355080" y="2343150"/>
-            <a:ext cx="5257800" cy="3086100"/>
+            <a:off x="6355080" y="2707165"/>
+            <a:ext cx="5257800" cy="2083749"/>
           </a:xfrm>
           <a:prstGeom prst="rect">
             <a:avLst/>
@@ -5931,7 +5949,7 @@
         <p:spPr>
           <a:xfrm>
             <a:off x="868680" y="2057400"/>
-            <a:ext cx="5303520" cy="1463040"/>
+            <a:ext cx="5303520" cy="1280160"/>
           </a:xfrm>
           <a:prstGeom prst="rect">
             <a:avLst/>
@@ -5962,7 +5980,7 @@
                 </a:solidFill>
                 <a:latin typeface="Calibri"/>
               </a:rPr>
-              <a:t>Un jumeau numérique calibré sur les essais réels génère une </a:t>
+              <a:t>Un jumeau calibré sur les essais réels génère une </a:t>
             </a:r>
             <a:r>
               <a:rPr sz="1400" b="1" i="0">
@@ -5980,29 +5998,25 @@
                 </a:solidFill>
                 <a:latin typeface="Calibri"/>
               </a:rPr>
-              <a:t>.</a:t>
-            </a:r>
-          </a:p>
-          <a:p>
-            <a:pPr algn="l">
-              <a:lnSpc>
-                <a:spcPct val="112000"/>
-              </a:lnSpc>
-              <a:spcBef>
-                <a:spcPts val="0"/>
-              </a:spcBef>
-              <a:spcAft>
-                <a:spcPts val="600"/>
-              </a:spcAft>
-            </a:pPr>
-            <a:r>
-              <a:rPr sz="1450" b="1" i="0">
+              <a:t> — l'un des </a:t>
+            </a:r>
+            <a:r>
+              <a:rPr sz="1400" b="1" i="0">
+                <a:solidFill>
+                  <a:srgbClr val="2C7A7B"/>
+                </a:solidFill>
+                <a:latin typeface="Calibri"/>
+              </a:rPr>
+              <a:t>trois estimateurs</a:t>
+            </a:r>
+            <a:r>
+              <a:rPr sz="1400" b="0" i="0">
                 <a:solidFill>
                   <a:srgbClr val="202B31"/>
                 </a:solidFill>
                 <a:latin typeface="Calibri"/>
               </a:rPr>
-              <a:t>Test « prédire-puis-confirmer » sur Run #21 :</a:t>
+              <a:t> confrontés en live (physique · XGBoost · jumeau).</a:t>
             </a:r>
           </a:p>
         </p:txBody>
@@ -6015,8 +6029,8 @@
         </p:nvSpPr>
         <p:spPr>
           <a:xfrm>
-            <a:off x="868680" y="3566160"/>
-            <a:ext cx="5303520" cy="1325880"/>
+            <a:off x="868680" y="3383280"/>
+            <a:ext cx="5303520" cy="1463040"/>
           </a:xfrm>
           <a:prstGeom prst="roundRect">
             <a:avLst/>
@@ -6061,8 +6075,8 @@
         </p:nvSpPr>
         <p:spPr>
           <a:xfrm>
-            <a:off x="1143000" y="3749039"/>
-            <a:ext cx="4846320" cy="1005840"/>
+            <a:off x="1143000" y="3547872"/>
+            <a:ext cx="4892040" cy="1143000"/>
           </a:xfrm>
           <a:prstGeom prst="rect">
             <a:avLst/>
@@ -6077,13 +6091,35 @@
           <a:p>
             <a:pPr algn="l">
               <a:lnSpc>
-                <a:spcPct val="115000"/>
-              </a:lnSpc>
-              <a:spcBef>
-                <a:spcPts val="0"/>
-              </a:spcBef>
-              <a:spcAft>
-                <a:spcPts val="700"/>
+                <a:spcPct val="112000"/>
+              </a:lnSpc>
+              <a:spcBef>
+                <a:spcPts val="0"/>
+              </a:spcBef>
+              <a:spcAft>
+                <a:spcPts val="400"/>
+              </a:spcAft>
+            </a:pPr>
+            <a:r>
+              <a:rPr sz="1300" b="1" i="0">
+                <a:solidFill>
+                  <a:srgbClr val="CADDDC"/>
+                </a:solidFill>
+                <a:latin typeface="Calibri"/>
+              </a:rPr>
+              <a:t>Deux tests « prédire-puis-confirmer » :</a:t>
+            </a:r>
+          </a:p>
+          <a:p>
+            <a:pPr algn="l">
+              <a:lnSpc>
+                <a:spcPct val="112000"/>
+              </a:lnSpc>
+              <a:spcBef>
+                <a:spcPts val="0"/>
+              </a:spcBef>
+              <a:spcAft>
+                <a:spcPts val="400"/>
               </a:spcAft>
             </a:pPr>
             <a:r>
@@ -6093,28 +6129,37 @@
                 </a:solidFill>
                 <a:latin typeface="Calibri"/>
               </a:rPr>
-              <a:t>Prédit avant l'essai : </a:t>
-            </a:r>
-            <a:r>
-              <a:rPr sz="1600" b="1" i="0">
+              <a:t>Run #21 : </a:t>
+            </a:r>
+            <a:r>
+              <a:rPr sz="1500" b="1" i="0">
                 <a:solidFill>
                   <a:srgbClr val="FFFFFF"/>
                 </a:solidFill>
                 <a:latin typeface="Georgia"/>
               </a:rPr>
-              <a:t>13 – 20,5 h</a:t>
+              <a:t>13,1 h</a:t>
+            </a:r>
+            <a:r>
+              <a:rPr sz="1250" b="1" i="0">
+                <a:solidFill>
+                  <a:srgbClr val="2C7A7B"/>
+                </a:solidFill>
+                <a:latin typeface="Calibri"/>
+              </a:rPr>
+              <a:t>   ✓ dans la bande</a:t>
             </a:r>
           </a:p>
           <a:p>
             <a:pPr algn="l">
               <a:lnSpc>
-                <a:spcPct val="115000"/>
-              </a:lnSpc>
-              <a:spcBef>
-                <a:spcPts val="0"/>
-              </a:spcBef>
-              <a:spcAft>
-                <a:spcPts val="700"/>
+                <a:spcPct val="112000"/>
+              </a:lnSpc>
+              <a:spcBef>
+                <a:spcPts val="0"/>
+              </a:spcBef>
+              <a:spcAft>
+                <a:spcPts val="400"/>
               </a:spcAft>
             </a:pPr>
             <a:r>
@@ -6124,25 +6169,25 @@
                 </a:solidFill>
                 <a:latin typeface="Calibri"/>
               </a:rPr>
-              <a:t>Rupture observée : </a:t>
-            </a:r>
-            <a:r>
-              <a:rPr sz="1600" b="1" i="0">
+              <a:t>Run #22 : </a:t>
+            </a:r>
+            <a:r>
+              <a:rPr sz="1500" b="1" i="0">
                 <a:solidFill>
                   <a:srgbClr val="C9601A"/>
                 </a:solidFill>
                 <a:latin typeface="Georgia"/>
               </a:rPr>
-              <a:t>13,1 h</a:t>
-            </a:r>
-            <a:r>
-              <a:rPr sz="1350" b="0" i="0">
-                <a:solidFill>
-                  <a:srgbClr val="FFFFFF"/>
-                </a:solidFill>
-                <a:latin typeface="Calibri"/>
-              </a:rPr>
-              <a:t>  ✓ dans la bande</a:t>
+              <a:t>11,95 h</a:t>
+            </a:r>
+            <a:r>
+              <a:rPr sz="1250" b="1" i="0">
+                <a:solidFill>
+                  <a:srgbClr val="C9601A"/>
+                </a:solidFill>
+                <a:latin typeface="Calibri"/>
+              </a:rPr>
+              <a:t>   ✗ en deçà (le plus rapide)</a:t>
             </a:r>
           </a:p>
         </p:txBody>
@@ -6155,8 +6200,8 @@
         </p:nvSpPr>
         <p:spPr>
           <a:xfrm>
-            <a:off x="868680" y="5166360"/>
-            <a:ext cx="5303520" cy="914400"/>
+            <a:off x="868680" y="5029200"/>
+            <a:ext cx="5303520" cy="1005840"/>
           </a:xfrm>
           <a:prstGeom prst="rect">
             <a:avLst/>
@@ -6171,7 +6216,7 @@
           <a:p>
             <a:pPr algn="l">
               <a:lnSpc>
-                <a:spcPct val="112000"/>
+                <a:spcPct val="108000"/>
               </a:lnSpc>
               <a:spcBef>
                 <a:spcPts val="0"/>
@@ -6181,31 +6226,67 @@
               </a:spcAft>
             </a:pPr>
             <a:r>
-              <a:rPr sz="1300" b="0" i="0">
+              <a:rPr sz="1250" b="0" i="0">
                 <a:solidFill>
                   <a:srgbClr val="202B31"/>
                 </a:solidFill>
                 <a:latin typeface="Calibri"/>
               </a:rPr>
-              <a:t>Enseignement : on ne prédit bien qu'une morphologie déjà observée </a:t>
-            </a:r>
-            <a:r>
-              <a:rPr sz="1300" b="1" i="0">
+              <a:t>Le jumeau </a:t>
+            </a:r>
+            <a:r>
+              <a:rPr sz="1250" b="1" i="0">
                 <a:solidFill>
                   <a:srgbClr val="C9601A"/>
                 </a:solidFill>
                 <a:latin typeface="Calibri"/>
               </a:rPr>
-              <a:t>≥ 2 fois</a:t>
-            </a:r>
-            <a:r>
-              <a:rPr sz="1300" b="0" i="0">
+              <a:t>interpole</a:t>
+            </a:r>
+            <a:r>
+              <a:rPr sz="1250" b="0" i="0">
                 <a:solidFill>
                   <a:srgbClr val="202B31"/>
                 </a:solidFill>
                 <a:latin typeface="Calibri"/>
               </a:rPr>
-              <a:t> — ce qui quantifie le besoin de répétition.</a:t>
+              <a:t> entre morphologies vues, il n'</a:t>
+            </a:r>
+            <a:r>
+              <a:rPr sz="1250" b="1" i="0">
+                <a:solidFill>
+                  <a:srgbClr val="C9601A"/>
+                </a:solidFill>
+                <a:latin typeface="Calibri"/>
+              </a:rPr>
+              <a:t>extrapole</a:t>
+            </a:r>
+            <a:r>
+              <a:rPr sz="1250" b="0" i="0">
+                <a:solidFill>
+                  <a:srgbClr val="202B31"/>
+                </a:solidFill>
+                <a:latin typeface="Calibri"/>
+              </a:rPr>
+              <a:t> pas. La prédictibilité tient à la répétition au sein d'une </a:t>
+            </a:r>
+            <a:r>
+              <a:rPr sz="1250" b="1" i="0">
+                <a:solidFill>
+                  <a:srgbClr val="2C7A7B"/>
+                </a:solidFill>
+                <a:latin typeface="Calibri"/>
+              </a:rPr>
+              <a:t>même morphologie</a:t>
+            </a:r>
+            <a:r>
+              <a:rPr sz="1250" b="0" i="0">
+                <a:solidFill>
+                  <a:srgbClr val="202B31"/>
+                </a:solidFill>
+                <a:latin typeface="Calibri"/>
+              </a:rPr>
+              <a:t>, pas au simple nombre d'essais.</a:t>
             </a:r>
           </a:p>
         </p:txBody>
@@ -14767,13 +14848,13 @@
           <a:p>
             <a:pPr algn="l">
               <a:lnSpc>
-                <a:spcPct val="110000"/>
-              </a:lnSpc>
-              <a:spcBef>
-                <a:spcPts val="0"/>
-              </a:spcBef>
-              <a:spcAft>
-                <a:spcPts val="1000"/>
+                <a:spcPct val="108000"/>
+              </a:lnSpc>
+              <a:spcBef>
+                <a:spcPts val="0"/>
+              </a:spcBef>
+              <a:spcAft>
+                <a:spcPts val="700"/>
               </a:spcAft>
             </a:pPr>
             <a:r>
@@ -14807,13 +14888,13 @@
           <a:p>
             <a:pPr algn="l">
               <a:lnSpc>
-                <a:spcPct val="110000"/>
-              </a:lnSpc>
-              <a:spcBef>
-                <a:spcPts val="0"/>
-              </a:spcBef>
-              <a:spcAft>
-                <a:spcPts val="1000"/>
+                <a:spcPct val="108000"/>
+              </a:lnSpc>
+              <a:spcBef>
+                <a:spcPts val="0"/>
+              </a:spcBef>
+              <a:spcAft>
+                <a:spcPts val="700"/>
               </a:spcAft>
             </a:pPr>
             <a:r>
@@ -14838,13 +14919,13 @@
           <a:p>
             <a:pPr algn="l">
               <a:lnSpc>
-                <a:spcPct val="110000"/>
-              </a:lnSpc>
-              <a:spcBef>
-                <a:spcPts val="0"/>
-              </a:spcBef>
-              <a:spcAft>
-                <a:spcPts val="1000"/>
+                <a:spcPct val="108000"/>
+              </a:lnSpc>
+              <a:spcBef>
+                <a:spcPts val="0"/>
+              </a:spcBef>
+              <a:spcAft>
+                <a:spcPts val="700"/>
               </a:spcAft>
             </a:pPr>
             <a:r>
@@ -14869,13 +14950,13 @@
           <a:p>
             <a:pPr algn="l">
               <a:lnSpc>
-                <a:spcPct val="110000"/>
-              </a:lnSpc>
-              <a:spcBef>
-                <a:spcPts val="0"/>
-              </a:spcBef>
-              <a:spcAft>
-                <a:spcPts val="1000"/>
+                <a:spcPct val="108000"/>
+              </a:lnSpc>
+              <a:spcBef>
+                <a:spcPts val="0"/>
+              </a:spcBef>
+              <a:spcAft>
+                <a:spcPts val="700"/>
               </a:spcAft>
             </a:pPr>
             <a:r>
@@ -14900,13 +14981,13 @@
           <a:p>
             <a:pPr algn="l">
               <a:lnSpc>
-                <a:spcPct val="110000"/>
-              </a:lnSpc>
-              <a:spcBef>
-                <a:spcPts val="0"/>
-              </a:spcBef>
-              <a:spcAft>
-                <a:spcPts val="1000"/>
+                <a:spcPct val="108000"/>
+              </a:lnSpc>
+              <a:spcBef>
+                <a:spcPts val="0"/>
+              </a:spcBef>
+              <a:spcAft>
+                <a:spcPts val="700"/>
               </a:spcAft>
             </a:pPr>
             <a:r>
@@ -14916,6 +14997,37 @@
                 </a:solidFill>
                 <a:latin typeface="Georgia"/>
               </a:rPr>
+              <a:t>Étalonnage — </a:t>
+            </a:r>
+            <a:r>
+              <a:rPr sz="1300" b="0" i="0">
+                <a:solidFill>
+                  <a:srgbClr val="202B31"/>
+                </a:solidFill>
+                <a:latin typeface="Calibri"/>
+              </a:rPr>
+              <a:t>par substitution sur résistances étalons ; un étalon de 4,7 Ω, lu 4,5–4,8 Ω, confirme la justesse (écart ≤ 4 %).</a:t>
+            </a:r>
+          </a:p>
+          <a:p>
+            <a:pPr algn="l">
+              <a:lnSpc>
+                <a:spcPct val="108000"/>
+              </a:lnSpc>
+              <a:spcBef>
+                <a:spcPts val="0"/>
+              </a:spcBef>
+              <a:spcAft>
+                <a:spcPts val="700"/>
+              </a:spcAft>
+            </a:pPr>
+            <a:r>
+              <a:rPr sz="1400" b="1" i="0">
+                <a:solidFill>
+                  <a:srgbClr val="202B31"/>
+                </a:solidFill>
+                <a:latin typeface="Georgia"/>
+              </a:rPr>
               <a:t>Température — </a:t>
             </a:r>
             <a:r>
@@ -14925,7 +15037,7 @@
                 </a:solidFill>
                 <a:latin typeface="Calibri"/>
               </a:rPr>
-              <a:t>DS18B20 protégé (tube + huile) pour un couplage thermique fiable ; cadence 30 s.</a:t>
+              <a:t>DS18B20 protégé (tube + huile) ; cadence 30 s.</a:t>
             </a:r>
           </a:p>
         </p:txBody>
@@ -15924,7 +16036,7 @@
       </p:sp>
       <p:pic>
         <p:nvPicPr>
-          <p:cNvPr id="6" name="Picture 5" descr="fig_iii3_r2_runs.png"/>
+          <p:cNvPr id="6" name="Picture 5" descr="fig_iii3_loro_evolution.png"/>
           <p:cNvPicPr>
             <a:picLocks noChangeAspect="1"/>
           </p:cNvPicPr>
@@ -15938,8 +16050,8 @@
         </p:blipFill>
         <p:spPr>
           <a:xfrm>
-            <a:off x="6446520" y="2792002"/>
-            <a:ext cx="5166360" cy="2554155"/>
+            <a:off x="6446520" y="2464736"/>
+            <a:ext cx="5166360" cy="3162966"/>
           </a:xfrm>
           <a:prstGeom prst="rect">
             <a:avLst/>
@@ -16041,7 +16153,7 @@
                 </a:solidFill>
                 <a:latin typeface="Calibri"/>
               </a:rPr>
-              <a:t>  (moy. LORO)</a:t>
+              <a:t>  (LORO actuel)</a:t>
             </a:r>
           </a:p>
         </p:txBody>
@@ -16086,7 +16198,7 @@
                 </a:solidFill>
                 <a:latin typeface="Calibri"/>
               </a:rPr>
-              <a:t>Run #12 : +0,50   ·   Run #16 : +0,07   —   bat les baselines</a:t>
+              <a:t>depuis −1,77 (couverture nulle)   —   bat les baselines</a:t>
             </a:r>
           </a:p>
         </p:txBody>
@@ -16115,23 +16227,63 @@
           <a:p>
             <a:pPr algn="l">
               <a:lnSpc>
-                <a:spcPct val="112000"/>
-              </a:lnSpc>
-              <a:spcBef>
-                <a:spcPts val="0"/>
-              </a:spcBef>
-              <a:spcAft>
-                <a:spcPts val="800"/>
-              </a:spcAft>
-            </a:pPr>
-            <a:r>
-              <a:rPr sz="1400" b="0" i="0">
+                <a:spcPct val="110000"/>
+              </a:lnSpc>
+              <a:spcBef>
+                <a:spcPts val="0"/>
+              </a:spcBef>
+              <a:spcAft>
+                <a:spcPts val="700"/>
+              </a:spcAft>
+            </a:pPr>
+            <a:r>
+              <a:rPr sz="1350" b="0" i="0">
                 <a:solidFill>
                   <a:srgbClr val="202B31"/>
                 </a:solidFill>
                 <a:latin typeface="Calibri"/>
               </a:rPr>
-              <a:t>Le résultat marquant n'est pas la valeur, mais sa </a:t>
+              <a:t>Une trajectoire, pas un point — couvrir et </a:t>
+            </a:r>
+            <a:r>
+              <a:rPr sz="1350" b="1" i="0">
+                <a:solidFill>
+                  <a:srgbClr val="2C7A7B"/>
+                </a:solidFill>
+                <a:latin typeface="Calibri"/>
+              </a:rPr>
+              <a:t>répéter</a:t>
+            </a:r>
+            <a:r>
+              <a:rPr sz="1350" b="0" i="0">
+                <a:solidFill>
+                  <a:srgbClr val="202B31"/>
+                </a:solidFill>
+                <a:latin typeface="Calibri"/>
+              </a:rPr>
+              <a:t> les conditions 30 °C a fait passer le LORO de −1,77 à +0,29.</a:t>
+            </a:r>
+          </a:p>
+          <a:p>
+            <a:pPr algn="l">
+              <a:lnSpc>
+                <a:spcPct val="110000"/>
+              </a:lnSpc>
+              <a:spcBef>
+                <a:spcPts val="0"/>
+              </a:spcBef>
+              <a:spcAft>
+                <a:spcPts val="700"/>
+              </a:spcAft>
+            </a:pPr>
+            <a:r>
+              <a:rPr sz="1350" b="0" i="0">
+                <a:solidFill>
+                  <a:srgbClr val="202B31"/>
+                </a:solidFill>
+                <a:latin typeface="Calibri"/>
+              </a:rPr>
+              <a:t>L'apport n'est pas la valeur mais la </a:t>
             </a:r>
             <a:r>
               <a:rPr sz="1400" b="1" i="0">
@@ -16143,93 +16295,53 @@
               <a:t>structure</a:t>
             </a:r>
             <a:r>
-              <a:rPr sz="1400" b="0" i="0">
+              <a:rPr sz="1350" b="0" i="0">
                 <a:solidFill>
                   <a:srgbClr val="202B31"/>
                 </a:solidFill>
                 <a:latin typeface="Calibri"/>
               </a:rPr>
-              <a:t> :</a:t>
+              <a:t> du R² : positif si conditions couvertes et répétées, négatif sinon.</a:t>
             </a:r>
           </a:p>
           <a:p>
             <a:pPr algn="l">
               <a:lnSpc>
-                <a:spcPct val="112000"/>
-              </a:lnSpc>
-              <a:spcBef>
-                <a:spcPts val="0"/>
-              </a:spcBef>
-              <a:spcAft>
-                <a:spcPts val="800"/>
-              </a:spcAft>
-            </a:pPr>
-            <a:r>
-              <a:rPr sz="1350" b="0" i="0">
+                <a:spcPct val="110000"/>
+              </a:lnSpc>
+              <a:spcBef>
+                <a:spcPts val="0"/>
+              </a:spcBef>
+              <a:spcAft>
+                <a:spcPts val="700"/>
+              </a:spcAft>
+            </a:pPr>
+            <a:r>
+              <a:rPr sz="1250" b="0" i="0">
                 <a:solidFill>
                   <a:srgbClr val="202B31"/>
                 </a:solidFill>
                 <a:latin typeface="Calibri"/>
               </a:rPr>
-              <a:t>positif là où les conditions du run testé sont </a:t>
-            </a:r>
-            <a:r>
-              <a:rPr sz="1350" b="1" i="0">
-                <a:solidFill>
-                  <a:srgbClr val="2C7A7B"/>
-                </a:solidFill>
-                <a:latin typeface="Calibri"/>
-              </a:rPr>
-              <a:t>couvertes et répétées</a:t>
-            </a:r>
-            <a:r>
-              <a:rPr sz="1350" b="0" i="0">
+              <a:t>Ajouter une morphologie non appariée le ramène à ≈ +0,20 — métrique encore </a:t>
+            </a:r>
+            <a:r>
+              <a:rPr sz="1250" b="1" i="0">
+                <a:solidFill>
+                  <a:srgbClr val="C9601A"/>
+                </a:solidFill>
+                <a:latin typeface="Calibri"/>
+              </a:rPr>
+              <a:t>bruitée</a:t>
+            </a:r>
+            <a:r>
+              <a:rPr sz="1250" b="0" i="0">
                 <a:solidFill>
                   <a:srgbClr val="202B31"/>
                 </a:solidFill>
                 <a:latin typeface="Calibri"/>
               </a:rPr>
-              <a:t>, négatif sinon.</a:t>
-            </a:r>
-          </a:p>
-          <a:p>
-            <a:pPr algn="l">
-              <a:lnSpc>
-                <a:spcPct val="112000"/>
-              </a:lnSpc>
-              <a:spcBef>
-                <a:spcPts val="0"/>
-              </a:spcBef>
-              <a:spcAft>
-                <a:spcPts val="800"/>
-              </a:spcAft>
-            </a:pPr>
-            <a:r>
-              <a:rPr sz="1350" b="0" i="0">
-                <a:solidFill>
-                  <a:srgbClr val="202B31"/>
-                </a:solidFill>
-                <a:latin typeface="Calibri"/>
-              </a:rPr>
-              <a:t>Ce n'est pas le volume brut qui compte, mais la </a:t>
-            </a:r>
-            <a:r>
-              <a:rPr sz="1350" b="1" i="0">
-                <a:solidFill>
-                  <a:srgbClr val="202B31"/>
-                </a:solidFill>
-                <a:latin typeface="Calibri"/>
-              </a:rPr>
-              <a:t>répétabilité des conditions</a:t>
-            </a:r>
-            <a:r>
-              <a:rPr sz="1350" b="0" i="0">
-                <a:solidFill>
-                  <a:srgbClr val="202B31"/>
-                </a:solidFill>
-                <a:latin typeface="Calibri"/>
-              </a:rPr>
-              <a:t>.</a:t>
+              <a:t> (peu d'essais).</a:t>
             </a:r>
           </a:p>
         </p:txBody>

</xml_diff>

<commit_message>
soutenance: passe anti-IA (pptx + pitch)
- pitch_soutenance.md : gras supprime (100 paires), em-dashes de prose -> virgules
- build_pptx.py : em-dashes des slides adoucis en virgules (gras conserve : normal sur slides)
- pptx regenere (17 slides), figures de-encombrees embarquees, chiffres inchanges

Co-Authored-By: Claude Opus 4.8 <noreply@anthropic.com>
</commit_message>
<xml_diff>
--- a/soutenance/Soutenance_Corrosion_BATOUMBI.pptx
+++ b/soutenance/Soutenance_Corrosion_BATOUMBI.pptx
@@ -3276,7 +3276,7 @@
                 </a:solidFill>
                 <a:latin typeface="Calibri"/>
               </a:rPr>
-              <a:t>RÉPUBLIQUE DU CAMEROUN  ·  ESTL LA SALLE — GÉNIE INDUSTRIEL &amp; MAINTENANCE</a:t>
+              <a:t>RÉPUBLIQUE DU CAMEROUN  ·  ESTL LA SALLE, GÉNIE INDUSTRIEL &amp; MAINTENANCE</a:t>
             </a:r>
           </a:p>
         </p:txBody>
@@ -3321,7 +3321,7 @@
                 </a:solidFill>
                 <a:latin typeface="Calibri"/>
               </a:rPr>
-              <a:t>Mémoire de Master 2 — Maintenance Industrielle et Productique</a:t>
+              <a:t>Mémoire de Master 2, Maintenance Industrielle et Productique</a:t>
             </a:r>
           </a:p>
         </p:txBody>
@@ -3763,7 +3763,7 @@
                 </a:solidFill>
                 <a:latin typeface="Calibri"/>
               </a:rPr>
-              <a:t>RÉSULTATS — OS3</a:t>
+              <a:t>RÉSULTATS, OS3</a:t>
             </a:r>
           </a:p>
         </p:txBody>
@@ -4033,7 +4033,7 @@
                 </a:solidFill>
                 <a:latin typeface="Calibri"/>
               </a:rPr>
-              <a:t>Run #15 — </a:t>
+              <a:t>Run #15, </a:t>
             </a:r>
             <a:r>
               <a:rPr sz="1250" b="0" i="0">
@@ -4131,7 +4131,7 @@
                 </a:solidFill>
                 <a:latin typeface="Calibri"/>
               </a:rPr>
-              <a:t>Run #17 — </a:t>
+              <a:t>Run #17, </a:t>
             </a:r>
             <a:r>
               <a:rPr sz="1250" b="0" i="0">
@@ -4937,7 +4937,7 @@
                 </a:solidFill>
                 <a:latin typeface="Calibri"/>
               </a:rPr>
-              <a:t>RÉSULTATS — OS4</a:t>
+              <a:t>RÉSULTATS, OS4</a:t>
             </a:r>
           </a:p>
         </p:txBody>
@@ -5085,7 +5085,7 @@
                 </a:solidFill>
                 <a:latin typeface="Calibri"/>
               </a:rPr>
-              <a:t> (CR, RUL, régime, section) est généré et tracé — sans appel externe.</a:t>
+              <a:t> (CR, RUL, régime, section) est généré et tracé, sans appel externe.</a:t>
             </a:r>
           </a:p>
         </p:txBody>
@@ -5445,7 +5445,7 @@
                 </a:solidFill>
                 <a:latin typeface="Calibri"/>
               </a:rPr>
-              <a:t>coût de licence nul — accessible aux PME africaines</a:t>
+              <a:t>coût de licence nul, accessible aux PME africaines</a:t>
             </a:r>
           </a:p>
         </p:txBody>
@@ -5998,7 +5998,7 @@
                 </a:solidFill>
                 <a:latin typeface="Calibri"/>
               </a:rPr>
-              <a:t> — l'un des </a:t>
+              <a:t>, l'un des </a:t>
             </a:r>
             <a:r>
               <a:rPr sz="1400" b="1" i="0">
@@ -6707,7 +6707,7 @@
                 </a:solidFill>
                 <a:latin typeface="Georgia"/>
               </a:rPr>
-              <a:t>Matériau  —  </a:t>
+              <a:t>Matériau ,  </a:t>
             </a:r>
             <a:r>
               <a:rPr sz="1350" b="0" i="0">
@@ -6851,7 +6851,7 @@
                 </a:solidFill>
                 <a:latin typeface="Georgia"/>
               </a:rPr>
-              <a:t>Effet acide-shunt  —  </a:t>
+              <a:t>Effet acide-shunt ,  </a:t>
             </a:r>
             <a:r>
               <a:rPr sz="1350" b="0" i="0">
@@ -6860,7 +6860,7 @@
                 </a:solidFill>
                 <a:latin typeface="Calibri"/>
               </a:rPr>
-              <a:t>en HCl concentré, l'électrolyte shunte la mesure — d'où l'emploi d'un fil fin.</a:t>
+              <a:t>en HCl concentré, l'électrolyte shunte la mesure, d'où l'emploi d'un fil fin.</a:t>
             </a:r>
           </a:p>
         </p:txBody>
@@ -6995,7 +6995,7 @@
                 </a:solidFill>
                 <a:latin typeface="Georgia"/>
               </a:rPr>
-              <a:t>Jeu de données  —  </a:t>
+              <a:t>Jeu de données ,  </a:t>
             </a:r>
             <a:r>
               <a:rPr sz="1350" b="0" i="0">
@@ -7139,7 +7139,7 @@
                 </a:solidFill>
                 <a:latin typeface="Georgia"/>
               </a:rPr>
-              <a:t>Couverture thermique  —  </a:t>
+              <a:t>Couverture thermique ,  </a:t>
             </a:r>
             <a:r>
               <a:rPr sz="1350" b="0" i="0">
@@ -7599,7 +7599,7 @@
                 </a:solidFill>
                 <a:latin typeface="Calibri"/>
               </a:rPr>
-              <a:t>La fiabilité du ML se lit dans la STRUCTURE du R² (positif si conditions couvertes et répétées) — rarement explicité dans la littérature.</a:t>
+              <a:t>La fiabilité du ML se lit dans la STRUCTURE du R² (positif si conditions couvertes et répétées), rarement explicité dans la littérature.</a:t>
             </a:r>
           </a:p>
         </p:txBody>
@@ -8343,7 +8343,7 @@
                 </a:solidFill>
                 <a:latin typeface="Georgia"/>
               </a:rPr>
-              <a:t>OS1 — </a:t>
+              <a:t>OS1, </a:t>
             </a:r>
             <a:r>
               <a:rPr sz="1400" b="0" i="0">
@@ -8450,7 +8450,7 @@
                 </a:solidFill>
                 <a:latin typeface="Georgia"/>
               </a:rPr>
-              <a:t>OS2 — </a:t>
+              <a:t>OS2, </a:t>
             </a:r>
             <a:r>
               <a:rPr sz="1400" b="0" i="0">
@@ -8459,7 +8459,7 @@
                 </a:solidFill>
                 <a:latin typeface="Calibri"/>
               </a:rPr>
-              <a:t>XGBoost prédit le CR et surpasse les baselines — sous condition de couverture.</a:t>
+              <a:t>XGBoost prédit le CR et surpasse les baselines, sous condition de couverture.</a:t>
             </a:r>
           </a:p>
         </p:txBody>
@@ -8557,7 +8557,7 @@
                 </a:solidFill>
                 <a:latin typeface="Georgia"/>
               </a:rPr>
-              <a:t>OS3 — </a:t>
+              <a:t>OS3, </a:t>
             </a:r>
             <a:r>
               <a:rPr sz="1400" b="0" i="0">
@@ -8664,7 +8664,7 @@
                 </a:solidFill>
                 <a:latin typeface="Georgia"/>
               </a:rPr>
-              <a:t>OS4 — </a:t>
+              <a:t>OS4, </a:t>
             </a:r>
             <a:r>
               <a:rPr sz="1400" b="0" i="0">
@@ -8718,7 +8718,7 @@
                 </a:solidFill>
                 <a:latin typeface="Calibri"/>
               </a:rPr>
-              <a:t>Objectifs partiellement atteints et en voie de consolidation — </a:t>
+              <a:t>Objectifs partiellement atteints et en voie de consolidation, </a:t>
             </a:r>
             <a:r>
               <a:rPr sz="1450" b="0" i="1">
@@ -9124,7 +9124,7 @@
                 </a:solidFill>
                 <a:latin typeface="Calibri"/>
               </a:rPr>
-              <a:t>Master 2 — Maintenance Industrielle et Productique  ·  ESTL La Salle  ·  2025–2026</a:t>
+              <a:t>Master 2, Maintenance Industrielle et Productique  ·  ESTL La Salle  ·  2025–2026</a:t>
             </a:r>
           </a:p>
         </p:txBody>
@@ -11432,7 +11432,7 @@
                 </a:solidFill>
                 <a:latin typeface="Georgia"/>
               </a:rPr>
-              <a:t>Pas de corrélation — </a:t>
+              <a:t>Pas de corrélation, </a:t>
             </a:r>
             <a:r>
               <a:rPr sz="1350" b="0" i="0">
@@ -11530,7 +11530,7 @@
                 </a:solidFill>
                 <a:latin typeface="Georgia"/>
               </a:rPr>
-              <a:t>Pas de RUL — </a:t>
+              <a:t>Pas de RUL, </a:t>
             </a:r>
             <a:r>
               <a:rPr sz="1350" b="0" i="0">
@@ -11628,7 +11628,7 @@
                 </a:solidFill>
                 <a:latin typeface="Georgia"/>
               </a:rPr>
-              <a:t>Boucle non prédictive — </a:t>
+              <a:t>Boucle non prédictive, </a:t>
             </a:r>
             <a:r>
               <a:rPr sz="1350" b="0" i="0">
@@ -11817,7 +11817,7 @@
                 </a:solidFill>
                 <a:latin typeface="Calibri"/>
               </a:rPr>
-              <a:t>Dans quelle mesure un système intégré — sonde ER instrumentée (ESP32/HX711/DS18B20), modèle XGBoost à double sortie CR + RUL en protocole </a:t>
+              <a:t>Dans quelle mesure un système intégré, sonde ER instrumentée (ESP32/HX711/DS18B20), modèle XGBoost à double sortie CR + RUL en protocole </a:t>
             </a:r>
             <a:r>
               <a:rPr sz="1450" b="0" i="1">
@@ -11835,7 +11835,7 @@
                 </a:solidFill>
                 <a:latin typeface="Calibri"/>
               </a:rPr>
-              <a:t>, et boucle décision → action — permet-il d'opérer la transition I3.0 → 4.0, transposable à COTCO comme aux PME industrielles africaines ?</a:t>
+              <a:t>, et boucle décision → action, permet-il d'opérer la transition I3.0 → 4.0, transposable à COTCO comme aux PME industrielles africaines ?</a:t>
             </a:r>
           </a:p>
         </p:txBody>
@@ -14750,7 +14750,7 @@
                 </a:solidFill>
                 <a:latin typeface="Calibri"/>
               </a:rPr>
-              <a:t>OS1 — DÉTECTION</a:t>
+              <a:t>OS1, DÉTECTION</a:t>
             </a:r>
           </a:p>
         </p:txBody>
@@ -14864,7 +14864,7 @@
                 </a:solidFill>
                 <a:latin typeface="Georgia"/>
               </a:rPr>
-              <a:t>Principe — </a:t>
+              <a:t>Principe, </a:t>
             </a:r>
             <a:r>
               <a:rPr sz="1300" b="0" i="0">
@@ -14904,7 +14904,7 @@
                 </a:solidFill>
                 <a:latin typeface="Georgia"/>
               </a:rPr>
-              <a:t>Montage retenu — </a:t>
+              <a:t>Montage retenu, </a:t>
             </a:r>
             <a:r>
               <a:rPr sz="1300" b="0" i="0">
@@ -14935,7 +14935,7 @@
                 </a:solidFill>
                 <a:latin typeface="Georgia"/>
               </a:rPr>
-              <a:t>Pont de Wheatstone abandonné — </a:t>
+              <a:t>Pont de Wheatstone abandonné, </a:t>
             </a:r>
             <a:r>
               <a:rPr sz="1300" b="0" i="0">
@@ -14966,7 +14966,7 @@
                 </a:solidFill>
                 <a:latin typeface="Georgia"/>
               </a:rPr>
-              <a:t>Valeurs justifiées — </a:t>
+              <a:t>Valeurs justifiées, </a:t>
             </a:r>
             <a:r>
               <a:rPr sz="1300" b="0" i="0">
@@ -14997,7 +14997,7 @@
                 </a:solidFill>
                 <a:latin typeface="Georgia"/>
               </a:rPr>
-              <a:t>Étalonnage — </a:t>
+              <a:t>Étalonnage, </a:t>
             </a:r>
             <a:r>
               <a:rPr sz="1300" b="0" i="0">
@@ -15028,7 +15028,7 @@
                 </a:solidFill>
                 <a:latin typeface="Georgia"/>
               </a:rPr>
-              <a:t>Température — </a:t>
+              <a:t>Température, </a:t>
             </a:r>
             <a:r>
               <a:rPr sz="1300" b="0" i="0">
@@ -15278,7 +15278,7 @@
                 </a:solidFill>
                 <a:latin typeface="Calibri"/>
               </a:rPr>
-              <a:t>OS2 — PRONOSTIC</a:t>
+              <a:t>OS2, PRONOSTIC</a:t>
             </a:r>
           </a:p>
         </p:txBody>
@@ -15984,7 +15984,7 @@
                 </a:solidFill>
                 <a:latin typeface="Calibri"/>
               </a:rPr>
-              <a:t>RÉSULTATS — OS2</a:t>
+              <a:t>RÉSULTATS, OS2</a:t>
             </a:r>
           </a:p>
         </p:txBody>
@@ -16029,7 +16029,7 @@
                 </a:solidFill>
                 <a:latin typeface="Georgia"/>
               </a:rPr>
-              <a:t>Le modèle généralise — là où les conditions sont couvertes</a:t>
+              <a:t>Le modèle généralise, là où les conditions sont couvertes</a:t>
             </a:r>
           </a:p>
         </p:txBody>
@@ -16198,7 +16198,7 @@
                 </a:solidFill>
                 <a:latin typeface="Calibri"/>
               </a:rPr>
-              <a:t>depuis −1,77 (couverture nulle)   —   bat les baselines</a:t>
+              <a:t>depuis −1,77 (couverture nulle), bat les baselines</a:t>
             </a:r>
           </a:p>
         </p:txBody>
@@ -16243,7 +16243,7 @@
                 </a:solidFill>
                 <a:latin typeface="Calibri"/>
               </a:rPr>
-              <a:t>Une trajectoire, pas un point — couvrir et </a:t>
+              <a:t>Une trajectoire, pas un point, couvrir et </a:t>
             </a:r>
             <a:r>
               <a:rPr sz="1350" b="1" i="0">
@@ -16323,7 +16323,7 @@
                 </a:solidFill>
                 <a:latin typeface="Calibri"/>
               </a:rPr>
-              <a:t>Ajouter une morphologie non appariée le ramène à ≈ +0,20 — métrique encore </a:t>
+              <a:t>Ajouter une morphologie non appariée le ramène à ≈ +0,20, métrique encore </a:t>
             </a:r>
             <a:r>
               <a:rPr sz="1250" b="1" i="0">

</xml_diff>

<commit_message>
soutenance: passe anti-IA du PowerPoint (texte des slides)
- repare les artefacts de la passe de surface : les paires libelle/description
  (slides Problematique, OS3, Limites, Conclusion) reprennent " : " au lieu
  d'une virgule maladroite ("Materiau ,  fil de fer" -> "Materiau : ...")
- kickers en " · " (OS1 · Detection, Resultats · OS2...) au lieu de la virgule
- retire "C'est precisement la transition" -> "C'est la transition ... engage"
- slide Resultats/Conclusion : tournures plus naturelles
Gras conserve (emphase normale sur slide). Chiffres/figures intacts. Rendu verifie.

Co-Authored-By: Claude Opus 4.8 <noreply@anthropic.com>
</commit_message>
<xml_diff>
--- a/soutenance/Soutenance_Corrosion_BATOUMBI.pptx
+++ b/soutenance/Soutenance_Corrosion_BATOUMBI.pptx
@@ -3763,7 +3763,7 @@
                 </a:solidFill>
                 <a:latin typeface="Calibri"/>
               </a:rPr>
-              <a:t>RÉSULTATS, OS3</a:t>
+              <a:t>RÉSULTATS · OS3</a:t>
             </a:r>
           </a:p>
         </p:txBody>
@@ -4033,7 +4033,7 @@
                 </a:solidFill>
                 <a:latin typeface="Calibri"/>
               </a:rPr>
-              <a:t>Run #15, </a:t>
+              <a:t>Run #15 : </a:t>
             </a:r>
             <a:r>
               <a:rPr sz="1250" b="0" i="0">
@@ -4131,7 +4131,7 @@
                 </a:solidFill>
                 <a:latin typeface="Calibri"/>
               </a:rPr>
-              <a:t>Run #17, </a:t>
+              <a:t>Run #17 : </a:t>
             </a:r>
             <a:r>
               <a:rPr sz="1250" b="0" i="0">
@@ -4937,7 +4937,7 @@
                 </a:solidFill>
                 <a:latin typeface="Calibri"/>
               </a:rPr>
-              <a:t>RÉSULTATS, OS4</a:t>
+              <a:t>RÉSULTATS · OS4</a:t>
             </a:r>
           </a:p>
         </p:txBody>
@@ -6707,7 +6707,7 @@
                 </a:solidFill>
                 <a:latin typeface="Georgia"/>
               </a:rPr>
-              <a:t>Matériau ,  </a:t>
+              <a:t>Matériau : </a:t>
             </a:r>
             <a:r>
               <a:rPr sz="1350" b="0" i="0">
@@ -6851,7 +6851,7 @@
                 </a:solidFill>
                 <a:latin typeface="Georgia"/>
               </a:rPr>
-              <a:t>Effet acide-shunt ,  </a:t>
+              <a:t>Effet acide-shunt : </a:t>
             </a:r>
             <a:r>
               <a:rPr sz="1350" b="0" i="0">
@@ -6995,7 +6995,7 @@
                 </a:solidFill>
                 <a:latin typeface="Georgia"/>
               </a:rPr>
-              <a:t>Jeu de données ,  </a:t>
+              <a:t>Jeu de données : </a:t>
             </a:r>
             <a:r>
               <a:rPr sz="1350" b="0" i="0">
@@ -7139,7 +7139,7 @@
                 </a:solidFill>
                 <a:latin typeface="Georgia"/>
               </a:rPr>
-              <a:t>Couverture thermique ,  </a:t>
+              <a:t>Couverture thermique : </a:t>
             </a:r>
             <a:r>
               <a:rPr sz="1350" b="0" i="0">
@@ -8343,7 +8343,7 @@
                 </a:solidFill>
                 <a:latin typeface="Georgia"/>
               </a:rPr>
-              <a:t>OS1, </a:t>
+              <a:t>OS1 : </a:t>
             </a:r>
             <a:r>
               <a:rPr sz="1400" b="0" i="0">
@@ -8450,7 +8450,7 @@
                 </a:solidFill>
                 <a:latin typeface="Georgia"/>
               </a:rPr>
-              <a:t>OS2, </a:t>
+              <a:t>OS2 : </a:t>
             </a:r>
             <a:r>
               <a:rPr sz="1400" b="0" i="0">
@@ -8557,7 +8557,7 @@
                 </a:solidFill>
                 <a:latin typeface="Georgia"/>
               </a:rPr>
-              <a:t>OS3, </a:t>
+              <a:t>OS3 : </a:t>
             </a:r>
             <a:r>
               <a:rPr sz="1400" b="0" i="0">
@@ -8664,7 +8664,7 @@
                 </a:solidFill>
                 <a:latin typeface="Georgia"/>
               </a:rPr>
-              <a:t>OS4, </a:t>
+              <a:t>OS4 : </a:t>
             </a:r>
             <a:r>
               <a:rPr sz="1400" b="0" i="0">
@@ -8718,7 +8718,7 @@
                 </a:solidFill>
                 <a:latin typeface="Calibri"/>
               </a:rPr>
-              <a:t>Objectifs partiellement atteints et en voie de consolidation, </a:t>
+              <a:t>Objectifs partiellement atteints, en cours de consolidation. </a:t>
             </a:r>
             <a:r>
               <a:rPr sz="1450" b="0" i="1">
@@ -8727,7 +8727,7 @@
                 </a:solidFill>
                 <a:latin typeface="Calibri"/>
               </a:rPr>
-              <a:t>un prototype doublement transposable, de la mesure à la décision.</a:t>
+              <a:t>Mais un prototype qui va de la mesure à la décision, transposable des deux côtés.</a:t>
             </a:r>
           </a:p>
         </p:txBody>
@@ -11039,7 +11039,7 @@
                 </a:solidFill>
                 <a:latin typeface="Calibri"/>
               </a:rPr>
-              <a:t>→ C'est précisément la transition </a:t>
+              <a:t>C'est la transition </a:t>
             </a:r>
             <a:r>
               <a:rPr sz="1450" b="1" i="0">
@@ -11048,7 +11048,7 @@
                 </a:solidFill>
                 <a:latin typeface="Calibri"/>
               </a:rPr>
-              <a:t>Industrie 3.0 → Industrie 4.0</a:t>
+              <a:t>Industrie 3.0 → 4.0</a:t>
             </a:r>
             <a:r>
               <a:rPr sz="1450" b="1" i="0">
@@ -11057,7 +11057,7 @@
                 </a:solidFill>
                 <a:latin typeface="Calibri"/>
               </a:rPr>
-              <a:t> que ce travail propose d'opérer, à coût maîtrisé.</a:t>
+              <a:t> que ce travail engage, à coût maîtrisé.</a:t>
             </a:r>
           </a:p>
         </p:txBody>
@@ -11432,7 +11432,7 @@
                 </a:solidFill>
                 <a:latin typeface="Georgia"/>
               </a:rPr>
-              <a:t>Pas de corrélation, </a:t>
+              <a:t>Pas de corrélation : </a:t>
             </a:r>
             <a:r>
               <a:rPr sz="1350" b="0" i="0">
@@ -11530,7 +11530,7 @@
                 </a:solidFill>
                 <a:latin typeface="Georgia"/>
               </a:rPr>
-              <a:t>Pas de RUL, </a:t>
+              <a:t>Pas de RUL : </a:t>
             </a:r>
             <a:r>
               <a:rPr sz="1350" b="0" i="0">
@@ -11628,7 +11628,7 @@
                 </a:solidFill>
                 <a:latin typeface="Georgia"/>
               </a:rPr>
-              <a:t>Boucle non prédictive, </a:t>
+              <a:t>Boucle non prédictive : </a:t>
             </a:r>
             <a:r>
               <a:rPr sz="1350" b="0" i="0">
@@ -14750,7 +14750,7 @@
                 </a:solidFill>
                 <a:latin typeface="Calibri"/>
               </a:rPr>
-              <a:t>OS1, DÉTECTION</a:t>
+              <a:t>OS1 · DÉTECTION</a:t>
             </a:r>
           </a:p>
         </p:txBody>
@@ -15278,7 +15278,7 @@
                 </a:solidFill>
                 <a:latin typeface="Calibri"/>
               </a:rPr>
-              <a:t>OS2, PRONOSTIC</a:t>
+              <a:t>OS2 · PRONOSTIC</a:t>
             </a:r>
           </a:p>
         </p:txBody>
@@ -15984,7 +15984,7 @@
                 </a:solidFill>
                 <a:latin typeface="Calibri"/>
               </a:rPr>
-              <a:t>RÉSULTATS, OS2</a:t>
+              <a:t>RÉSULTATS · OS2</a:t>
             </a:r>
           </a:p>
         </p:txBody>
@@ -16198,7 +16198,7 @@
                 </a:solidFill>
                 <a:latin typeface="Calibri"/>
               </a:rPr>
-              <a:t>depuis −1,77 (couverture nulle), bat les baselines</a:t>
+              <a:t>depuis −1,77 (couverture nulle) · bat les références</a:t>
             </a:r>
           </a:p>
         </p:txBody>
@@ -16243,7 +16243,7 @@
                 </a:solidFill>
                 <a:latin typeface="Calibri"/>
               </a:rPr>
-              <a:t>Une trajectoire, pas un point, couvrir et </a:t>
+              <a:t>Une trajectoire, pas un point : couvrir et </a:t>
             </a:r>
             <a:r>
               <a:rPr sz="1350" b="1" i="0">

</xml_diff>